<commit_message>
update BWU-BTS-25-503 python ppt and pdf
</commit_message>
<xml_diff>
--- a/3rdSem/Assignments/pptx/python/BWU-BTS-25-503.pptx
+++ b/3rdSem/Assignments/pptx/python/BWU-BTS-25-503.pptx
@@ -8763,7 +8763,9 @@
       <p:sp>
         <p:nvSpPr>
           <p:cNvPr id="3" name="Bullets 3"/>
-          <p:cNvSpPr txBox="1"/>
+          <p:cNvSpPr txBox="1">
+            <a:spLocks/>
+          </p:cNvSpPr>
           <p:nvPr/>
         </p:nvSpPr>
         <p:spPr>
@@ -9039,6 +9041,46 @@
                 <a:cs typeface="+mn-lt"/>
               </a:rPr>
               <a:t>Course lecture notes : Python modules 2, 4 &amp; 5 (Strings, Functions/Modules, Exceptions &amp; OOP).</a:t>
+            </a:r>
+          </a:p>
+          <a:p>
+            <a:pPr marL="228600" indent="-228600">
+              <a:spcAft>
+                <a:spcPts val="1000"/>
+              </a:spcAft>
+              <a:buClr>
+                <a:schemeClr val="accent2"/>
+              </a:buClr>
+              <a:buFont typeface="Arial"/>
+              <a:buChar char="•"/>
+            </a:pPr>
+            <a:r>
+              <a:rPr lang="en-US" sz="1400" dirty="0" err="1">
+                <a:solidFill>
+                  <a:schemeClr val="tx2"/>
+                </a:solidFill>
+                <a:cs typeface="+mn-lt"/>
+              </a:rPr>
+              <a:t>Github</a:t>
+            </a:r>
+            <a:r>
+              <a:rPr lang="en-US" sz="1400" dirty="0">
+                <a:solidFill>
+                  <a:schemeClr val="tx2"/>
+                </a:solidFill>
+                <a:cs typeface="+mn-lt"/>
+              </a:rPr>
+              <a:t>: </a:t>
+            </a:r>
+            <a:r>
+              <a:rPr lang="en-US" sz="1400" dirty="0">
+                <a:solidFill>
+                  <a:schemeClr val="tx2"/>
+                </a:solidFill>
+                <a:cs typeface="+mn-lt"/>
+                <a:hlinkClick r:id="rId3"/>
+              </a:rPr>
+              <a:t>Click here</a:t>
             </a:r>
             <a:endParaRPr lang="en-US" sz="1400" dirty="0"/>
           </a:p>
@@ -9115,7 +9157,7 @@
           <p:nvPr/>
         </p:nvPicPr>
         <p:blipFill>
-          <a:blip r:embed="rId3"/>
+          <a:blip r:embed="rId4"/>
           <a:stretch>
             <a:fillRect/>
           </a:stretch>
@@ -9237,7 +9279,7 @@
           <p:nvPr/>
         </p:nvPicPr>
         <p:blipFill>
-          <a:blip r:embed="rId4"/>
+          <a:blip r:embed="rId5"/>
           <a:stretch>
             <a:fillRect/>
           </a:stretch>

</xml_diff>